<commit_message>
Update documents of the project
</commit_message>
<xml_diff>
--- a/assets/slides.pptx
+++ b/assets/slides.pptx
@@ -236,7 +236,7 @@
           <a:p>
             <a:fld id="{48B45424-6BAC-416C-8F6C-5F9DE854A36B}" type="datetimeFigureOut">
               <a:rPr lang="en-US" smtClean="0"/>
-              <a:t>6/17/2026</a:t>
+              <a:t>6/18/2026</a:t>
             </a:fld>
             <a:endParaRPr lang="en-US"/>
           </a:p>
@@ -414,7 +414,7 @@
           <a:p>
             <a:fld id="{6B733702-C25A-40B9-9167-54BAA79B29B0}" type="datetimeFigureOut">
               <a:rPr lang="en-US" smtClean="0"/>
-              <a:t>6/17/2026</a:t>
+              <a:t>6/18/2026</a:t>
             </a:fld>
             <a:endParaRPr lang="en-US"/>
           </a:p>
@@ -800,7 +800,7 @@
             <a:fld id="{F70EAA40-3A53-4A3D-924A-D38F1059C7D5}" type="datetime1">
               <a:rPr lang="en-US" smtClean="0"/>
               <a:pPr/>
-              <a:t>6/17/2026</a:t>
+              <a:t>6/18/2026</a:t>
             </a:fld>
             <a:endParaRPr lang="en-US"/>
           </a:p>
@@ -1134,7 +1134,7 @@
             <a:fld id="{F70EAA40-3A53-4A3D-924A-D38F1059C7D5}" type="datetime1">
               <a:rPr lang="en-US" smtClean="0"/>
               <a:pPr/>
-              <a:t>6/17/2026</a:t>
+              <a:t>6/18/2026</a:t>
             </a:fld>
             <a:endParaRPr lang="en-US"/>
           </a:p>
@@ -1468,7 +1468,7 @@
             <a:fld id="{F70EAA40-3A53-4A3D-924A-D38F1059C7D5}" type="datetime1">
               <a:rPr lang="en-US" smtClean="0"/>
               <a:pPr/>
-              <a:t>6/17/2026</a:t>
+              <a:t>6/18/2026</a:t>
             </a:fld>
             <a:endParaRPr lang="en-US"/>
           </a:p>
@@ -2154,7 +2154,7 @@
             <a:fld id="{F70EAA40-3A53-4A3D-924A-D38F1059C7D5}" type="datetime1">
               <a:rPr lang="en-US" smtClean="0"/>
               <a:pPr/>
-              <a:t>6/17/2026</a:t>
+              <a:t>6/18/2026</a:t>
             </a:fld>
             <a:endParaRPr lang="en-US"/>
           </a:p>
@@ -2344,7 +2344,7 @@
             <a:fld id="{F70EAA40-3A53-4A3D-924A-D38F1059C7D5}" type="datetime1">
               <a:rPr lang="en-US" smtClean="0"/>
               <a:pPr/>
-              <a:t>6/17/2026</a:t>
+              <a:t>6/18/2026</a:t>
             </a:fld>
             <a:endParaRPr lang="en-US"/>
           </a:p>
@@ -2927,7 +2927,7 @@
             <a:fld id="{F70EAA40-3A53-4A3D-924A-D38F1059C7D5}" type="datetime1">
               <a:rPr lang="en-US" smtClean="0"/>
               <a:pPr/>
-              <a:t>6/17/2026</a:t>
+              <a:t>6/18/2026</a:t>
             </a:fld>
             <a:endParaRPr lang="en-US"/>
           </a:p>
@@ -3113,7 +3113,7 @@
             <a:fld id="{F70EAA40-3A53-4A3D-924A-D38F1059C7D5}" type="datetime1">
               <a:rPr lang="en-US" smtClean="0"/>
               <a:pPr/>
-              <a:t>6/17/2026</a:t>
+              <a:t>6/18/2026</a:t>
             </a:fld>
             <a:endParaRPr lang="en-US"/>
           </a:p>
@@ -3449,7 +3449,7 @@
             <a:fld id="{F70EAA40-3A53-4A3D-924A-D38F1059C7D5}" type="datetime1">
               <a:rPr lang="en-US" smtClean="0"/>
               <a:pPr/>
-              <a:t>6/17/2026</a:t>
+              <a:t>6/18/2026</a:t>
             </a:fld>
             <a:endParaRPr lang="en-US"/>
           </a:p>
@@ -4053,11 +4053,19 @@
               <a:t>phần</a:t>
             </a:r>
             <a:r>
+              <a:rPr lang="en-US" sz="400" dirty="0"/>
+              <a:t> </a:t>
+            </a:r>
+            <a:r>
               <a:rPr lang="en-US" sz="2800" dirty="0"/>
               <a:t>:</a:t>
             </a:r>
             <a:r>
               <a:rPr lang="en-US" sz="2800" b="0" dirty="0"/>
+              <a:t>      </a:t>
+            </a:r>
+            <a:r>
+              <a:rPr lang="en-US" sz="2000" b="0" dirty="0"/>
               <a:t> </a:t>
             </a:r>
             <a:r>
@@ -4139,7 +4147,15 @@
             </a:r>
             <a:r>
               <a:rPr lang="en-US" sz="2800" b="0" dirty="0"/>
-              <a:t> 8</a:t>
+              <a:t>            </a:t>
+            </a:r>
+            <a:r>
+              <a:rPr lang="en-US" sz="2000" b="0" dirty="0"/>
+              <a:t> </a:t>
+            </a:r>
+            <a:r>
+              <a:rPr lang="en-US" sz="2800" b="0" dirty="0"/>
+              <a:t>8</a:t>
             </a:r>
           </a:p>
           <a:p>
@@ -4161,7 +4177,7 @@
             </a:r>
             <a:r>
               <a:rPr lang="en-US" sz="2800" b="0" dirty="0"/>
-              <a:t> 12</a:t>
+              <a:t>           12</a:t>
             </a:r>
           </a:p>
         </p:txBody>
@@ -4264,8 +4280,8 @@
           </a:p>
         </p:txBody>
       </p:sp>
-      <mc:AlternateContent xmlns:mc="http://schemas.openxmlformats.org/markup-compatibility/2006" xmlns:a14="http://schemas.microsoft.com/office/drawing/2010/main">
-        <mc:Choice Requires="a14">
+      <mc:AlternateContent xmlns:mc="http://schemas.openxmlformats.org/markup-compatibility/2006">
+        <mc:Choice xmlns:a14="http://schemas.microsoft.com/office/drawing/2010/main" Requires="a14">
           <p:sp>
             <p:nvSpPr>
               <p:cNvPr id="4" name="Text Placeholder 3">
@@ -5093,14 +5109,6 @@
                 </a:r>
                 <a:r>
                   <a:rPr lang="en-US" dirty="0" err="1"/>
-                  <a:t>bỏ</a:t>
-                </a:r>
-                <a:r>
-                  <a:rPr lang="en-US" dirty="0"/>
-                  <a:t> </a:t>
-                </a:r>
-                <a:r>
-                  <a:rPr lang="en-US" dirty="0" err="1"/>
                   <a:t>được</a:t>
                 </a:r>
                 <a:r>
@@ -5135,7 +5143,7 @@
             </p:txBody>
           </p:sp>
         </mc:Choice>
-        <mc:Fallback xmlns="">
+        <mc:Fallback>
           <p:sp>
             <p:nvSpPr>
               <p:cNvPr id="4" name="Text Placeholder 3">
@@ -6959,8 +6967,8 @@
           </a:p>
         </p:txBody>
       </p:sp>
-      <mc:AlternateContent xmlns:mc="http://schemas.openxmlformats.org/markup-compatibility/2006" xmlns:a14="http://schemas.microsoft.com/office/drawing/2010/main">
-        <mc:Choice Requires="a14">
+      <mc:AlternateContent xmlns:mc="http://schemas.openxmlformats.org/markup-compatibility/2006">
+        <mc:Choice xmlns:a14="http://schemas.microsoft.com/office/drawing/2010/main" Requires="a14">
           <p:sp>
             <p:nvSpPr>
               <p:cNvPr id="4" name="Text Placeholder 3">
@@ -7041,9 +7049,88 @@
               </a:p>
               <a:p>
                 <a:pPr algn="just"/>
-                <a:r>
-                  <a:rPr lang="en-US" dirty="0" err="1"/>
-                  <a:t>Không</a:t>
+                <a14:m>
+                  <m:oMath xmlns:m="http://schemas.openxmlformats.org/officeDocument/2006/math">
+                    <m:r>
+                      <a:rPr lang="en-US" b="0" i="1" smtClean="0">
+                        <a:latin typeface="Cambria Math" panose="02040503050406030204" pitchFamily="18" charset="0"/>
+                      </a:rPr>
+                      <m:t>𝑛𝑒𝑥</m:t>
+                    </m:r>
+                    <m:sSub>
+                      <m:sSubPr>
+                        <m:ctrlPr>
+                          <a:rPr lang="en-US" b="0" i="1" smtClean="0">
+                            <a:latin typeface="Cambria Math" panose="02040503050406030204" pitchFamily="18" charset="0"/>
+                          </a:rPr>
+                        </m:ctrlPr>
+                      </m:sSubPr>
+                      <m:e>
+                        <m:r>
+                          <a:rPr lang="en-US" b="0" i="1" smtClean="0">
+                            <a:latin typeface="Cambria Math" panose="02040503050406030204" pitchFamily="18" charset="0"/>
+                          </a:rPr>
+                          <m:t>𝑡</m:t>
+                        </m:r>
+                      </m:e>
+                      <m:sub>
+                        <m:r>
+                          <a:rPr lang="en-US" b="0" i="1" smtClean="0">
+                            <a:latin typeface="Cambria Math" panose="02040503050406030204" pitchFamily="18" charset="0"/>
+                          </a:rPr>
+                          <m:t>𝑖</m:t>
+                        </m:r>
+                      </m:sub>
+                    </m:sSub>
+                  </m:oMath>
+                </a14:m>
+                <a:r>
+                  <a:rPr lang="en-US" dirty="0"/>
+                  <a:t> </a:t>
+                </a:r>
+                <a:r>
+                  <a:rPr lang="en-US" dirty="0" err="1"/>
+                  <a:t>là</a:t>
+                </a:r>
+                <a:r>
+                  <a:rPr lang="en-US" dirty="0"/>
+                  <a:t> </a:t>
+                </a:r>
+                <a:r>
+                  <a:rPr lang="en-US" dirty="0" err="1"/>
+                  <a:t>biến</a:t>
+                </a:r>
+                <a:r>
+                  <a:rPr lang="en-US" dirty="0"/>
+                  <a:t> </a:t>
+                </a:r>
+                <a:r>
+                  <a:rPr lang="en-US" dirty="0" err="1"/>
+                  <a:t>quyết</a:t>
+                </a:r>
+                <a:r>
+                  <a:rPr lang="en-US" dirty="0"/>
+                  <a:t> </a:t>
+                </a:r>
+                <a:r>
+                  <a:rPr lang="en-US" dirty="0" err="1"/>
+                  <a:t>định</a:t>
+                </a:r>
+                <a:r>
+                  <a:rPr lang="en-US" dirty="0"/>
+                  <a:t> </a:t>
+                </a:r>
+                <a:r>
+                  <a:rPr lang="en-US" dirty="0" err="1"/>
+                  <a:t>nên</a:t>
+                </a:r>
+                <a:r>
+                  <a:rPr lang="en-US" dirty="0"/>
+                  <a:t> </a:t>
+                </a:r>
+                <a:r>
+                  <a:rPr lang="en-US" dirty="0" err="1"/>
+                  <a:t>không</a:t>
                 </a:r>
                 <a:r>
                   <a:rPr lang="en-US" dirty="0"/>
@@ -7059,15 +7146,7 @@
                 </a:r>
                 <a:r>
                   <a:rPr lang="en-US" dirty="0" err="1"/>
-                  <a:t>sử</a:t>
-                </a:r>
-                <a:r>
-                  <a:rPr lang="en-US" dirty="0"/>
-                  <a:t> </a:t>
-                </a:r>
-                <a:r>
-                  <a:rPr lang="en-US" dirty="0" err="1"/>
-                  <a:t>dụng</a:t>
+                  <a:t>dùng</a:t>
                 </a:r>
                 <a:r>
                   <a:rPr lang="en-US" dirty="0"/>
@@ -7403,7 +7482,7 @@
             </p:txBody>
           </p:sp>
         </mc:Choice>
-        <mc:Fallback xmlns="">
+        <mc:Fallback>
           <p:sp>
             <p:nvSpPr>
               <p:cNvPr id="4" name="Text Placeholder 3">
@@ -7541,8 +7620,8 @@
           </a:p>
         </p:txBody>
       </p:sp>
-      <mc:AlternateContent xmlns:mc="http://schemas.openxmlformats.org/markup-compatibility/2006" xmlns:a14="http://schemas.microsoft.com/office/drawing/2010/main">
-        <mc:Choice Requires="a14">
+      <mc:AlternateContent xmlns:mc="http://schemas.openxmlformats.org/markup-compatibility/2006">
+        <mc:Choice xmlns:a14="http://schemas.microsoft.com/office/drawing/2010/main" Requires="a14">
           <p:sp>
             <p:nvSpPr>
               <p:cNvPr id="4" name="Text Placeholder 3">
@@ -7992,6 +8071,111 @@
                 </a:r>
               </a:p>
               <a:p>
+                <a:pPr marL="0" indent="0" algn="just">
+                  <a:buNone/>
+                </a:pPr>
+                <a:r>
+                  <a:rPr lang="en-US" dirty="0"/>
+                  <a:t>(Hai </a:t>
+                </a:r>
+                <a:r>
+                  <a:rPr lang="en-US" dirty="0" err="1"/>
+                  <a:t>cách</a:t>
+                </a:r>
+                <a:r>
+                  <a:rPr lang="en-US" dirty="0"/>
+                  <a:t> </a:t>
+                </a:r>
+                <a:r>
+                  <a:rPr lang="en-US" dirty="0" err="1"/>
+                  <a:t>đều</a:t>
+                </a:r>
+                <a:r>
+                  <a:rPr lang="en-US" dirty="0"/>
+                  <a:t> </a:t>
+                </a:r>
+                <a:r>
+                  <a:rPr lang="en-US" dirty="0" err="1"/>
+                  <a:t>dừng</a:t>
+                </a:r>
+                <a:r>
+                  <a:rPr lang="en-US" dirty="0"/>
+                  <a:t> </a:t>
+                </a:r>
+                <a:r>
+                  <a:rPr lang="en-US" dirty="0" err="1"/>
+                  <a:t>lập</a:t>
+                </a:r>
+                <a:r>
+                  <a:rPr lang="en-US" dirty="0"/>
+                  <a:t> </a:t>
+                </a:r>
+                <a:r>
+                  <a:rPr lang="en-US" dirty="0" err="1"/>
+                  <a:t>tức</a:t>
+                </a:r>
+                <a:r>
+                  <a:rPr lang="en-US" dirty="0"/>
+                  <a:t> </a:t>
+                </a:r>
+                <a:r>
+                  <a:rPr lang="en-US" dirty="0" err="1"/>
+                  <a:t>khi</a:t>
+                </a:r>
+                <a:r>
+                  <a:rPr lang="en-US" dirty="0"/>
+                  <a:t> </a:t>
+                </a:r>
+                <a:r>
+                  <a:rPr lang="en-US" dirty="0" err="1"/>
+                  <a:t>không</a:t>
+                </a:r>
+                <a:r>
+                  <a:rPr lang="en-US" dirty="0"/>
+                  <a:t> </a:t>
+                </a:r>
+                <a:r>
+                  <a:rPr lang="en-US" dirty="0" err="1"/>
+                  <a:t>còn</a:t>
+                </a:r>
+                <a:r>
+                  <a:rPr lang="en-US" dirty="0"/>
+                  <a:t> </a:t>
+                </a:r>
+                <a:r>
+                  <a:rPr lang="en-US" dirty="0" err="1"/>
+                  <a:t>khách</a:t>
+                </a:r>
+                <a:r>
+                  <a:rPr lang="en-US" dirty="0"/>
+                  <a:t> </a:t>
+                </a:r>
+                <a:r>
+                  <a:rPr lang="en-US" dirty="0" err="1"/>
+                  <a:t>nào</a:t>
+                </a:r>
+                <a:r>
+                  <a:rPr lang="en-US" dirty="0"/>
+                  <a:t> </a:t>
+                </a:r>
+                <a:r>
+                  <a:rPr lang="en-US" dirty="0" err="1"/>
+                  <a:t>thỏa</a:t>
+                </a:r>
+                <a:r>
+                  <a:rPr lang="en-US" dirty="0"/>
+                  <a:t> </a:t>
+                </a:r>
+                <a:r>
+                  <a:rPr lang="en-US" dirty="0" err="1"/>
+                  <a:t>mãn</a:t>
+                </a:r>
+                <a:r>
+                  <a:rPr lang="en-US" dirty="0"/>
+                  <a:t>.)</a:t>
+                </a:r>
+              </a:p>
+              <a:p>
                 <a:pPr algn="just">
                   <a:buFont typeface="Cambria Math" panose="02040503050406030204" pitchFamily="18" charset="0"/>
                   <a:buChar char="⇒"/>
@@ -8268,7 +8452,7 @@
             </p:txBody>
           </p:sp>
         </mc:Choice>
-        <mc:Fallback xmlns="">
+        <mc:Fallback>
           <p:sp>
             <p:nvSpPr>
               <p:cNvPr id="4" name="Text Placeholder 3">
@@ -8289,7 +8473,7 @@
               <a:blipFill>
                 <a:blip r:embed="rId2"/>
                 <a:stretch>
-                  <a:fillRect l="-1406" t="-2019" r="-1477"/>
+                  <a:fillRect l="-1477" t="-2019" r="-1477"/>
                 </a:stretch>
               </a:blipFill>
             </p:spPr>
@@ -8406,8 +8590,8 @@
           </a:p>
         </p:txBody>
       </p:sp>
-      <mc:AlternateContent xmlns:mc="http://schemas.openxmlformats.org/markup-compatibility/2006" xmlns:a14="http://schemas.microsoft.com/office/drawing/2010/main">
-        <mc:Choice Requires="a14">
+      <mc:AlternateContent xmlns:mc="http://schemas.openxmlformats.org/markup-compatibility/2006">
+        <mc:Choice xmlns:a14="http://schemas.microsoft.com/office/drawing/2010/main" Requires="a14">
           <p:sp>
             <p:nvSpPr>
               <p:cNvPr id="4" name="Text Placeholder 3">
@@ -8571,70 +8755,6 @@
                 </a:r>
                 <a:r>
                   <a:rPr lang="en-US" dirty="0"/>
-                  <a:t>, </a:t>
-                </a:r>
-                <a:r>
-                  <a:rPr lang="en-US" dirty="0" err="1"/>
-                  <a:t>tạm</a:t>
-                </a:r>
-                <a:r>
-                  <a:rPr lang="en-US" dirty="0"/>
-                  <a:t> </a:t>
-                </a:r>
-                <a:r>
-                  <a:rPr lang="en-US" dirty="0" err="1"/>
-                  <a:t>bỏ</a:t>
-                </a:r>
-                <a:r>
-                  <a:rPr lang="en-US" dirty="0"/>
-                  <a:t> qua </a:t>
-                </a:r>
-                <a:r>
-                  <a:rPr lang="en-US" dirty="0" err="1"/>
-                  <a:t>điều</a:t>
-                </a:r>
-                <a:r>
-                  <a:rPr lang="en-US" dirty="0"/>
-                  <a:t> </a:t>
-                </a:r>
-                <a:r>
-                  <a:rPr lang="en-US" dirty="0" err="1"/>
-                  <a:t>kiện</a:t>
-                </a:r>
-                <a:r>
-                  <a:rPr lang="en-US" dirty="0"/>
-                  <a:t> </a:t>
-                </a:r>
-                <a:r>
-                  <a:rPr lang="en-US" dirty="0" err="1"/>
-                  <a:t>cửa</a:t>
-                </a:r>
-                <a:r>
-                  <a:rPr lang="en-US" dirty="0"/>
-                  <a:t> </a:t>
-                </a:r>
-                <a:r>
-                  <a:rPr lang="en-US" dirty="0" err="1"/>
-                  <a:t>sổ</a:t>
-                </a:r>
-                <a:r>
-                  <a:rPr lang="en-US" dirty="0"/>
-                  <a:t> </a:t>
-                </a:r>
-                <a:r>
-                  <a:rPr lang="en-US" dirty="0" err="1"/>
-                  <a:t>thời</a:t>
-                </a:r>
-                <a:r>
-                  <a:rPr lang="en-US" dirty="0"/>
-                  <a:t> </a:t>
-                </a:r>
-                <a:r>
-                  <a:rPr lang="en-US" dirty="0" err="1"/>
-                  <a:t>gian</a:t>
-                </a:r>
-                <a:r>
-                  <a:rPr lang="en-US" dirty="0"/>
                   <a:t>.</a:t>
                 </a:r>
               </a:p>
@@ -8715,7 +8835,48 @@
                 </a:r>
                 <a:r>
                   <a:rPr lang="en-US" dirty="0"/>
-                  <a:t>, </a:t>
+                  <a:t>.</a:t>
+                </a:r>
+              </a:p>
+              <a:p>
+                <a:pPr marL="0" indent="0" algn="just">
+                  <a:buNone/>
+                </a:pPr>
+                <a:r>
+                  <a:rPr lang="en-US" dirty="0"/>
+                  <a:t>(Hai </a:t>
+                </a:r>
+                <a:r>
+                  <a:rPr lang="en-US" dirty="0" err="1"/>
+                  <a:t>cách</a:t>
+                </a:r>
+                <a:r>
+                  <a:rPr lang="en-US" dirty="0"/>
+                  <a:t> </a:t>
+                </a:r>
+                <a:r>
+                  <a:rPr lang="en-US" dirty="0" err="1"/>
+                  <a:t>khởi</a:t>
+                </a:r>
+                <a:r>
+                  <a:rPr lang="en-US" dirty="0"/>
+                  <a:t> </a:t>
+                </a:r>
+                <a:r>
+                  <a:rPr lang="en-US" dirty="0" err="1"/>
+                  <a:t>tạo</a:t>
+                </a:r>
+                <a:r>
+                  <a:rPr lang="en-US" dirty="0"/>
+                  <a:t> </a:t>
+                </a:r>
+                <a:r>
+                  <a:rPr lang="en-US" dirty="0" err="1"/>
+                  <a:t>đều</a:t>
+                </a:r>
+                <a:r>
+                  <a:rPr lang="en-US" dirty="0"/>
+                  <a:t> </a:t>
                 </a:r>
                 <a:r>
                   <a:rPr lang="en-US" dirty="0" err="1"/>
@@ -8779,7 +8940,7 @@
                 </a:r>
                 <a:r>
                   <a:rPr lang="en-US" dirty="0"/>
-                  <a:t>.</a:t>
+                  <a:t>.)</a:t>
                 </a:r>
               </a:p>
               <a:p>
@@ -9238,7 +9399,7 @@
             </p:txBody>
           </p:sp>
         </mc:Choice>
-        <mc:Fallback xmlns="">
+        <mc:Fallback>
           <p:sp>
             <p:nvSpPr>
               <p:cNvPr id="4" name="Text Placeholder 3">
@@ -9259,7 +9420,7 @@
               <a:blipFill>
                 <a:blip r:embed="rId2"/>
                 <a:stretch>
-                  <a:fillRect l="-1406" t="-2019" r="-1477" b="-950"/>
+                  <a:fillRect l="-1477" t="-2019" r="-1477" b="-3444"/>
                 </a:stretch>
               </a:blipFill>
             </p:spPr>
@@ -9733,7 +9894,7 @@
             </a:r>
             <a:r>
               <a:rPr lang="en-US" dirty="0"/>
-              <a:t> (First improvement).</a:t>
+              <a:t> (first improvement).</a:t>
             </a:r>
           </a:p>
           <a:p>
@@ -12803,7 +12964,7 @@
           <a:p>
             <a:r>
               <a:rPr lang="en-US" dirty="0" err="1"/>
-              <a:t>Kết</a:t>
+              <a:t>Không</a:t>
             </a:r>
             <a:r>
               <a:rPr lang="en-US" dirty="0"/>
@@ -12811,7 +12972,7 @@
             </a:r>
             <a:r>
               <a:rPr lang="en-US" dirty="0" err="1"/>
-              <a:t>quả</a:t>
+              <a:t>chênh</a:t>
             </a:r>
             <a:r>
               <a:rPr lang="en-US" dirty="0"/>
@@ -12819,23 +12980,7 @@
             </a:r>
             <a:r>
               <a:rPr lang="en-US" dirty="0" err="1"/>
-              <a:t>giữa</a:t>
-            </a:r>
-            <a:r>
-              <a:rPr lang="en-US" dirty="0"/>
-              <a:t> </a:t>
-            </a:r>
-            <a:r>
-              <a:rPr lang="en-US" dirty="0" err="1"/>
-              <a:t>ba</a:t>
-            </a:r>
-            <a:r>
-              <a:rPr lang="en-US" dirty="0"/>
-              <a:t> </a:t>
-            </a:r>
-            <a:r>
-              <a:rPr lang="en-US" dirty="0" err="1"/>
-              <a:t>lần</a:t>
+              <a:t>lệch</a:t>
             </a:r>
             <a:endParaRPr lang="en-US" dirty="0"/>
           </a:p>
@@ -12845,41 +12990,39 @@
             </a:pPr>
             <a:r>
               <a:rPr lang="en-US" dirty="0" err="1"/>
+              <a:t>nhiều</a:t>
+            </a:r>
+            <a:r>
+              <a:rPr lang="en-US" dirty="0"/>
+              <a:t> </a:t>
+            </a:r>
+            <a:r>
+              <a:rPr lang="en-US" dirty="0" err="1"/>
+              <a:t>giữa</a:t>
+            </a:r>
+            <a:r>
+              <a:rPr lang="en-US" dirty="0"/>
+              <a:t> </a:t>
+            </a:r>
+            <a:r>
+              <a:rPr lang="en-US" dirty="0" err="1"/>
+              <a:t>ba</a:t>
+            </a:r>
+            <a:r>
+              <a:rPr lang="en-US" dirty="0"/>
+              <a:t> </a:t>
+            </a:r>
+            <a:r>
+              <a:rPr lang="en-US" dirty="0" err="1"/>
+              <a:t>lần</a:t>
+            </a:r>
+            <a:r>
+              <a:rPr lang="en-US" dirty="0"/>
+              <a:t> </a:t>
+            </a:r>
+            <a:r>
+              <a:rPr lang="en-US" dirty="0" err="1"/>
               <a:t>chạy</a:t>
-            </a:r>
-            <a:r>
-              <a:rPr lang="en-US" dirty="0"/>
-              <a:t> </a:t>
-            </a:r>
-            <a:r>
-              <a:rPr lang="en-US" dirty="0" err="1"/>
-              <a:t>không</a:t>
-            </a:r>
-            <a:r>
-              <a:rPr lang="en-US" dirty="0"/>
-              <a:t> </a:t>
-            </a:r>
-            <a:r>
-              <a:rPr lang="en-US" dirty="0" err="1"/>
-              <a:t>chênh</a:t>
-            </a:r>
-            <a:endParaRPr lang="en-US" dirty="0"/>
-          </a:p>
-          <a:p>
-            <a:pPr marL="0" indent="0">
-              <a:buNone/>
-            </a:pPr>
-            <a:r>
-              <a:rPr lang="en-US" dirty="0" err="1"/>
-              <a:t>lệch</a:t>
-            </a:r>
-            <a:r>
-              <a:rPr lang="en-US" dirty="0"/>
-              <a:t> </a:t>
-            </a:r>
-            <a:r>
-              <a:rPr lang="en-US" dirty="0" err="1"/>
-              <a:t>nhiều</a:t>
             </a:r>
             <a:r>
               <a:rPr lang="en-US" dirty="0"/>
@@ -13304,7 +13447,7 @@
           <a:p>
             <a:r>
               <a:rPr lang="en-US" dirty="0" err="1"/>
-              <a:t>Kết</a:t>
+              <a:t>Chênh</a:t>
             </a:r>
             <a:r>
               <a:rPr lang="en-US" dirty="0"/>
@@ -13312,7 +13455,7 @@
             </a:r>
             <a:r>
               <a:rPr lang="en-US" dirty="0" err="1"/>
-              <a:t>quả</a:t>
+              <a:t>lệch</a:t>
             </a:r>
             <a:r>
               <a:rPr lang="en-US" dirty="0"/>
@@ -13320,7 +13463,7 @@
             </a:r>
             <a:r>
               <a:rPr lang="en-US" dirty="0" err="1"/>
-              <a:t>giữa</a:t>
+              <a:t>không</a:t>
             </a:r>
             <a:r>
               <a:rPr lang="en-US" dirty="0"/>
@@ -13328,7 +13471,7 @@
             </a:r>
             <a:r>
               <a:rPr lang="en-US" dirty="0" err="1"/>
-              <a:t>ba</a:t>
+              <a:t>quá</a:t>
             </a:r>
             <a:r>
               <a:rPr lang="en-US" dirty="0"/>
@@ -13336,15 +13479,7 @@
             </a:r>
             <a:r>
               <a:rPr lang="en-US" dirty="0" err="1"/>
-              <a:t>lần</a:t>
-            </a:r>
-            <a:r>
-              <a:rPr lang="en-US" dirty="0"/>
-              <a:t> </a:t>
-            </a:r>
-            <a:r>
-              <a:rPr lang="en-US" dirty="0" err="1"/>
-              <a:t>chạy</a:t>
+              <a:t>lớn</a:t>
             </a:r>
             <a:endParaRPr lang="en-US" dirty="0"/>
           </a:p>
@@ -13354,7 +13489,7 @@
             </a:pPr>
             <a:r>
               <a:rPr lang="en-US" dirty="0" err="1"/>
-              <a:t>không</a:t>
+              <a:t>giữa</a:t>
             </a:r>
             <a:r>
               <a:rPr lang="en-US" dirty="0"/>
@@ -13362,7 +13497,7 @@
             </a:r>
             <a:r>
               <a:rPr lang="en-US" dirty="0" err="1"/>
-              <a:t>chênh</a:t>
+              <a:t>ba</a:t>
             </a:r>
             <a:r>
               <a:rPr lang="en-US" dirty="0"/>
@@ -13370,7 +13505,7 @@
             </a:r>
             <a:r>
               <a:rPr lang="en-US" dirty="0" err="1"/>
-              <a:t>lệch</a:t>
+              <a:t>lần</a:t>
             </a:r>
             <a:r>
               <a:rPr lang="en-US" dirty="0"/>
@@ -13378,7 +13513,7 @@
             </a:r>
             <a:r>
               <a:rPr lang="en-US" dirty="0" err="1"/>
-              <a:t>nhiều</a:t>
+              <a:t>chạy</a:t>
             </a:r>
             <a:r>
               <a:rPr lang="en-US" dirty="0"/>
@@ -13404,15 +13539,7 @@
             </a:r>
             <a:r>
               <a:rPr lang="en-US" dirty="0" err="1"/>
-              <a:t>cải</a:t>
-            </a:r>
-            <a:r>
-              <a:rPr lang="en-US" dirty="0"/>
-              <a:t> </a:t>
-            </a:r>
-            <a:r>
-              <a:rPr lang="en-US" dirty="0" err="1"/>
-              <a:t>thiện</a:t>
+              <a:t>tốt</a:t>
             </a:r>
             <a:r>
               <a:rPr lang="en-US" dirty="0"/>
@@ -13424,11 +13551,19 @@
             </a:r>
             <a:r>
               <a:rPr lang="en-US" dirty="0"/>
+              <a:t>, </a:t>
+            </a:r>
+            <a:r>
+              <a:rPr lang="en-US" dirty="0" err="1"/>
+              <a:t>ổn</a:t>
+            </a:r>
+            <a:r>
+              <a:rPr lang="en-US" dirty="0"/>
               <a:t> </a:t>
             </a:r>
             <a:r>
               <a:rPr lang="en-US" dirty="0" err="1"/>
-              <a:t>và</a:t>
+              <a:t>định</a:t>
             </a:r>
             <a:endParaRPr lang="en-US" dirty="0"/>
           </a:p>
@@ -13438,6 +13573,30 @@
             </a:pPr>
             <a:r>
               <a:rPr lang="en-US" dirty="0" err="1"/>
+              <a:t>hơn</a:t>
+            </a:r>
+            <a:r>
+              <a:rPr lang="en-US" dirty="0"/>
+              <a:t> </a:t>
+            </a:r>
+            <a:r>
+              <a:rPr lang="en-US" dirty="0" err="1"/>
+              <a:t>và</a:t>
+            </a:r>
+            <a:r>
+              <a:rPr lang="en-US" dirty="0"/>
+              <a:t> </a:t>
+            </a:r>
+            <a:r>
+              <a:rPr lang="en-US" dirty="0" err="1"/>
+              <a:t>có</a:t>
+            </a:r>
+            <a:r>
+              <a:rPr lang="en-US" dirty="0"/>
+              <a:t> </a:t>
+            </a:r>
+            <a:r>
+              <a:rPr lang="en-US" dirty="0" err="1"/>
               <a:t>thời</a:t>
             </a:r>
             <a:r>
@@ -13456,26 +13615,7 @@
               <a:rPr lang="en-US" dirty="0" err="1"/>
               <a:t>chạy</a:t>
             </a:r>
-            <a:r>
-              <a:rPr lang="en-US" dirty="0"/>
-              <a:t> </a:t>
-            </a:r>
-            <a:r>
-              <a:rPr lang="en-US" dirty="0" err="1"/>
-              <a:t>ngắn</a:t>
-            </a:r>
-            <a:r>
-              <a:rPr lang="en-US" dirty="0"/>
-              <a:t> </a:t>
-            </a:r>
-            <a:r>
-              <a:rPr lang="en-US" dirty="0" err="1"/>
-              <a:t>hơn</a:t>
-            </a:r>
-            <a:r>
-              <a:rPr lang="en-US" dirty="0"/>
-              <a:t> so</a:t>
-            </a:r>
+            <a:endParaRPr lang="en-US" dirty="0"/>
           </a:p>
           <a:p>
             <a:pPr marL="0" indent="0">
@@ -13483,6 +13623,22 @@
             </a:pPr>
             <a:r>
               <a:rPr lang="en-US" dirty="0" err="1"/>
+              <a:t>ngắn</a:t>
+            </a:r>
+            <a:r>
+              <a:rPr lang="en-US" dirty="0"/>
+              <a:t> </a:t>
+            </a:r>
+            <a:r>
+              <a:rPr lang="en-US" dirty="0" err="1"/>
+              <a:t>hơn</a:t>
+            </a:r>
+            <a:r>
+              <a:rPr lang="en-US" dirty="0"/>
+              <a:t> so </a:t>
+            </a:r>
+            <a:r>
+              <a:rPr lang="en-US" dirty="0" err="1"/>
               <a:t>với</a:t>
             </a:r>
             <a:r>
@@ -13509,10 +13665,12 @@
               <a:rPr lang="en-US" dirty="0" err="1"/>
               <a:t>leo</a:t>
             </a:r>
-            <a:r>
-              <a:rPr lang="en-US" dirty="0"/>
-              <a:t> </a:t>
-            </a:r>
+            <a:endParaRPr lang="en-US" dirty="0"/>
+          </a:p>
+          <a:p>
+            <a:pPr marL="0" indent="0">
+              <a:buNone/>
+            </a:pPr>
             <a:r>
               <a:rPr lang="en-US" dirty="0" err="1"/>
               <a:t>đồi</a:t>
@@ -13679,7 +13837,15 @@
             </a:pPr>
             <a:r>
               <a:rPr lang="en-US" b="1" dirty="0" err="1"/>
-              <a:t>Độ</a:t>
+              <a:t>Mức</a:t>
+            </a:r>
+            <a:r>
+              <a:rPr lang="en-US" b="1" dirty="0"/>
+              <a:t> </a:t>
+            </a:r>
+            <a:r>
+              <a:rPr lang="en-US" b="1" dirty="0" err="1"/>
+              <a:t>độ</a:t>
             </a:r>
             <a:r>
               <a:rPr lang="en-US" b="1" dirty="0"/>
@@ -14260,8 +14426,8 @@
           </a:p>
         </p:txBody>
       </p:sp>
-      <mc:AlternateContent xmlns:mc="http://schemas.openxmlformats.org/markup-compatibility/2006" xmlns:a14="http://schemas.microsoft.com/office/drawing/2010/main">
-        <mc:Choice Requires="a14">
+      <mc:AlternateContent xmlns:mc="http://schemas.openxmlformats.org/markup-compatibility/2006">
+        <mc:Choice xmlns:a14="http://schemas.microsoft.com/office/drawing/2010/main" Requires="a14">
           <p:sp>
             <p:nvSpPr>
               <p:cNvPr id="4" name="Text Placeholder 3">
@@ -14288,12 +14454,24 @@
                   <a:buAutoNum type="arabicPeriod" startAt="6"/>
                 </a:pPr>
                 <a:r>
+                  <a:rPr lang="en-US" b="1" dirty="0" err="1"/>
+                  <a:t>Thống</a:t>
+                </a:r>
+                <a:r>
                   <a:rPr lang="en-US" b="1" dirty="0"/>
-                  <a:t>Chi </a:t>
+                  <a:t> </a:t>
                 </a:r>
                 <a:r>
                   <a:rPr lang="en-US" b="1" dirty="0" err="1"/>
-                  <a:t>tiết</a:t>
+                  <a:t>kê</a:t>
+                </a:r>
+                <a:r>
+                  <a:rPr lang="en-US" b="1" dirty="0"/>
+                  <a:t> </a:t>
+                </a:r>
+                <a:r>
+                  <a:rPr lang="en-US" b="1" dirty="0" err="1"/>
+                  <a:t>về</a:t>
                 </a:r>
                 <a:r>
                   <a:rPr lang="en-US" b="1" dirty="0"/>
@@ -14475,15 +14653,11 @@
                 </a:r>
                 <a:r>
                   <a:rPr lang="en-US" dirty="0"/>
-                  <a:t>       </a:t>
+                  <a:t>:        </a:t>
                 </a:r>
                 <a:r>
                   <a:rPr lang="en-US" sz="1800" dirty="0"/>
                   <a:t> </a:t>
-                </a:r>
-                <a:r>
-                  <a:rPr lang="en-US" dirty="0"/>
-                  <a:t>: </a:t>
                 </a:r>
                 <a14:m>
                   <m:oMath xmlns:m="http://schemas.openxmlformats.org/officeDocument/2006/math">
@@ -14766,7 +14940,7 @@
             </p:txBody>
           </p:sp>
         </mc:Choice>
-        <mc:Fallback xmlns="">
+        <mc:Fallback>
           <p:sp>
             <p:nvSpPr>
               <p:cNvPr id="4" name="Text Placeholder 3">
@@ -15223,8 +15397,8 @@
           </a:p>
         </p:txBody>
       </p:sp>
-      <mc:AlternateContent xmlns:mc="http://schemas.openxmlformats.org/markup-compatibility/2006" xmlns:a14="http://schemas.microsoft.com/office/drawing/2010/main">
-        <mc:Choice Requires="a14">
+      <mc:AlternateContent xmlns:mc="http://schemas.openxmlformats.org/markup-compatibility/2006">
+        <mc:Choice xmlns:a14="http://schemas.microsoft.com/office/drawing/2010/main" Requires="a14">
           <p:sp>
             <p:nvSpPr>
               <p:cNvPr id="4" name="Text Placeholder 3">
@@ -15253,7 +15427,23 @@
                 </a:r>
                 <a:r>
                   <a:rPr lang="vi-VN" dirty="0"/>
-                  <a:t>giao hàng lấy hàng ở kho (điểm </a:t>
+                  <a:t>giao hàng </a:t>
+                </a:r>
+                <a:r>
+                  <a:rPr lang="en-US" dirty="0" err="1"/>
+                  <a:t>đi</a:t>
+                </a:r>
+                <a:r>
+                  <a:rPr lang="en-US" dirty="0"/>
+                  <a:t> </a:t>
+                </a:r>
+                <a:r>
+                  <a:rPr lang="en-US" dirty="0" err="1"/>
+                  <a:t>từ</a:t>
+                </a:r>
+                <a:r>
+                  <a:rPr lang="vi-VN" dirty="0"/>
+                  <a:t> kho (điểm </a:t>
                 </a:r>
                 <a14:m>
                   <m:oMath xmlns:m="http://schemas.openxmlformats.org/officeDocument/2006/math">
@@ -15761,7 +15951,7 @@
             </p:txBody>
           </p:sp>
         </mc:Choice>
-        <mc:Fallback xmlns="">
+        <mc:Fallback>
           <p:sp>
             <p:nvSpPr>
               <p:cNvPr id="4" name="Text Placeholder 3">
@@ -15899,8 +16089,8 @@
           </a:p>
         </p:txBody>
       </p:sp>
-      <mc:AlternateContent xmlns:mc="http://schemas.openxmlformats.org/markup-compatibility/2006" xmlns:a14="http://schemas.microsoft.com/office/drawing/2010/main">
-        <mc:Choice Requires="a14">
+      <mc:AlternateContent xmlns:mc="http://schemas.openxmlformats.org/markup-compatibility/2006">
+        <mc:Choice xmlns:a14="http://schemas.microsoft.com/office/drawing/2010/main" Requires="a14">
           <p:sp>
             <p:nvSpPr>
               <p:cNvPr id="4" name="Text Placeholder 3">
@@ -15990,6 +16180,30 @@
                   <a:rPr lang="en-US" dirty="0" err="1"/>
                   <a:t>lời</a:t>
                 </a:r>
+                <a:r>
+                  <a:rPr lang="en-US" dirty="0"/>
+                  <a:t> </a:t>
+                </a:r>
+                <a:r>
+                  <a:rPr lang="en-US" dirty="0" err="1"/>
+                  <a:t>giải</a:t>
+                </a:r>
+                <a:r>
+                  <a:rPr lang="en-US" dirty="0"/>
+                  <a:t> </a:t>
+                </a:r>
+                <a:r>
+                  <a:rPr lang="en-US" dirty="0" err="1"/>
+                  <a:t>bộ</a:t>
+                </a:r>
+                <a:r>
+                  <a:rPr lang="en-US" dirty="0"/>
+                  <a:t> </a:t>
+                </a:r>
+                <a:r>
+                  <a:rPr lang="en-US" dirty="0" err="1"/>
+                  <a:t>phận</a:t>
+                </a:r>
                 <a:endParaRPr lang="en-US" dirty="0"/>
               </a:p>
               <a:p>
@@ -15998,23 +16212,39 @@
                 </a:pPr>
                 <a:r>
                   <a:rPr lang="en-US" dirty="0" err="1"/>
-                  <a:t>giải</a:t>
-                </a:r>
-                <a:r>
-                  <a:rPr lang="en-US" dirty="0"/>
-                  <a:t> </a:t>
-                </a:r>
-                <a:r>
-                  <a:rPr lang="en-US" dirty="0" err="1"/>
-                  <a:t>bộ</a:t>
-                </a:r>
-                <a:r>
-                  <a:rPr lang="en-US" dirty="0"/>
-                  <a:t> </a:t>
-                </a:r>
-                <a:r>
-                  <a:rPr lang="en-US" dirty="0" err="1"/>
-                  <a:t>phận</a:t>
+                  <a:t>bằng</a:t>
+                </a:r>
+                <a:r>
+                  <a:rPr lang="en-US" dirty="0"/>
+                  <a:t> </a:t>
+                </a:r>
+                <a:r>
+                  <a:rPr lang="en-US" dirty="0" err="1"/>
+                  <a:t>cách</a:t>
+                </a:r>
+                <a:r>
+                  <a:rPr lang="en-US" dirty="0"/>
+                  <a:t> </a:t>
+                </a:r>
+                <a:r>
+                  <a:rPr lang="en-US" dirty="0" err="1"/>
+                  <a:t>chọn</a:t>
+                </a:r>
+                <a:r>
+                  <a:rPr lang="en-US" dirty="0"/>
+                  <a:t> </a:t>
+                </a:r>
+                <a:r>
+                  <a:rPr lang="en-US" dirty="0" err="1"/>
+                  <a:t>khách</a:t>
+                </a:r>
+                <a:r>
+                  <a:rPr lang="en-US" dirty="0"/>
+                  <a:t> </a:t>
+                </a:r>
+                <a:r>
+                  <a:rPr lang="en-US" dirty="0" err="1"/>
+                  <a:t>tiếp</a:t>
                 </a:r>
                 <a:endParaRPr lang="en-US" dirty="0"/>
               </a:p>
@@ -16024,23 +16254,47 @@
                 </a:pPr>
                 <a:r>
                   <a:rPr lang="en-US" dirty="0" err="1"/>
-                  <a:t>bằng</a:t>
-                </a:r>
-                <a:r>
-                  <a:rPr lang="en-US" dirty="0"/>
-                  <a:t> </a:t>
-                </a:r>
-                <a:r>
-                  <a:rPr lang="en-US" dirty="0" err="1"/>
-                  <a:t>cách</a:t>
-                </a:r>
-                <a:r>
-                  <a:rPr lang="en-US" dirty="0"/>
-                  <a:t> </a:t>
-                </a:r>
-                <a:r>
-                  <a:rPr lang="en-US" dirty="0" err="1"/>
-                  <a:t>chọn</a:t>
+                  <a:t>theo</a:t>
+                </a:r>
+                <a:r>
+                  <a:rPr lang="en-US" dirty="0"/>
+                  <a:t> </a:t>
+                </a:r>
+                <a:r>
+                  <a:rPr lang="en-US" dirty="0" err="1"/>
+                  <a:t>mà</a:t>
+                </a:r>
+                <a:r>
+                  <a:rPr lang="en-US" dirty="0"/>
+                  <a:t> </a:t>
+                </a:r>
+                <a:r>
+                  <a:rPr lang="en-US" dirty="0" err="1"/>
+                  <a:t>vẫn</a:t>
+                </a:r>
+                <a:r>
+                  <a:rPr lang="en-US" dirty="0"/>
+                  <a:t> </a:t>
+                </a:r>
+                <a:r>
+                  <a:rPr lang="en-US" dirty="0" err="1"/>
+                  <a:t>còn</a:t>
+                </a:r>
+                <a:r>
+                  <a:rPr lang="en-US" dirty="0"/>
+                  <a:t> </a:t>
+                </a:r>
+                <a:r>
+                  <a:rPr lang="en-US" dirty="0" err="1"/>
+                  <a:t>thỏa</a:t>
+                </a:r>
+                <a:r>
+                  <a:rPr lang="en-US" dirty="0"/>
+                  <a:t> </a:t>
+                </a:r>
+                <a:r>
+                  <a:rPr lang="en-US" dirty="0" err="1"/>
+                  <a:t>mãn</a:t>
                 </a:r>
                 <a:endParaRPr lang="en-US" dirty="0"/>
               </a:p>
@@ -16050,23 +16304,82 @@
                 </a:pPr>
                 <a:r>
                   <a:rPr lang="en-US" dirty="0" err="1"/>
-                  <a:t>khách</a:t>
-                </a:r>
-                <a:r>
-                  <a:rPr lang="en-US" dirty="0"/>
-                  <a:t> </a:t>
-                </a:r>
-                <a:r>
-                  <a:rPr lang="en-US" dirty="0" err="1"/>
-                  <a:t>tiếp</a:t>
-                </a:r>
-                <a:r>
-                  <a:rPr lang="en-US" dirty="0"/>
-                  <a:t> </a:t>
-                </a:r>
-                <a:r>
-                  <a:rPr lang="en-US" dirty="0" err="1"/>
-                  <a:t>theo</a:t>
+                  <a:t>ràng</a:t>
+                </a:r>
+                <a:r>
+                  <a:rPr lang="en-US" dirty="0"/>
+                  <a:t> </a:t>
+                </a:r>
+                <a:r>
+                  <a:rPr lang="en-US" dirty="0" err="1"/>
+                  <a:t>buộc</a:t>
+                </a:r>
+                <a:r>
+                  <a:rPr lang="en-US" dirty="0"/>
+                  <a:t> </a:t>
+                </a:r>
+                <a:r>
+                  <a:rPr lang="en-US" dirty="0" err="1"/>
+                  <a:t>cửa</a:t>
+                </a:r>
+                <a:r>
+                  <a:rPr lang="en-US" dirty="0"/>
+                  <a:t> </a:t>
+                </a:r>
+                <a:r>
+                  <a:rPr lang="en-US" dirty="0" err="1"/>
+                  <a:t>sổ</a:t>
+                </a:r>
+                <a:r>
+                  <a:rPr lang="en-US" dirty="0"/>
+                  <a:t> </a:t>
+                </a:r>
+                <a:r>
+                  <a:rPr lang="en-US" dirty="0" err="1"/>
+                  <a:t>thời</a:t>
+                </a:r>
+                <a:r>
+                  <a:rPr lang="en-US" dirty="0"/>
+                  <a:t> </a:t>
+                </a:r>
+                <a:r>
+                  <a:rPr lang="en-US" dirty="0" err="1"/>
+                  <a:t>gian</a:t>
+                </a:r>
+                <a:r>
+                  <a:rPr lang="en-US" dirty="0"/>
+                  <a:t>.</a:t>
+                </a:r>
+              </a:p>
+              <a:p>
+                <a:pPr algn="just"/>
+                <a:r>
+                  <a:rPr lang="en-US" dirty="0" err="1"/>
+                  <a:t>Nhánh</a:t>
+                </a:r>
+                <a:r>
+                  <a:rPr lang="en-US" dirty="0"/>
+                  <a:t> </a:t>
+                </a:r>
+                <a:r>
+                  <a:rPr lang="en-US" dirty="0" err="1"/>
+                  <a:t>cận</a:t>
+                </a:r>
+                <a:r>
+                  <a:rPr lang="en-US" dirty="0"/>
+                  <a:t>: </a:t>
+                </a:r>
+                <a:r>
+                  <a:rPr lang="en-US" dirty="0" err="1"/>
+                  <a:t>Khoảng</a:t>
+                </a:r>
+                <a:r>
+                  <a:rPr lang="en-US" dirty="0"/>
+                  <a:t> </a:t>
+                </a:r>
+                <a:r>
+                  <a:rPr lang="en-US" dirty="0" err="1"/>
+                  <a:t>cách</a:t>
                 </a:r>
                 <a:endParaRPr lang="en-US" dirty="0"/>
               </a:p>
@@ -16076,23 +16389,39 @@
                 </a:pPr>
                 <a:r>
                   <a:rPr lang="en-US" dirty="0" err="1"/>
-                  <a:t>thỏa</a:t>
-                </a:r>
-                <a:r>
-                  <a:rPr lang="en-US" dirty="0"/>
-                  <a:t> </a:t>
-                </a:r>
-                <a:r>
-                  <a:rPr lang="en-US" dirty="0" err="1"/>
-                  <a:t>mãn</a:t>
-                </a:r>
-                <a:r>
-                  <a:rPr lang="en-US" dirty="0"/>
-                  <a:t> </a:t>
-                </a:r>
-                <a:r>
-                  <a:rPr lang="en-US" dirty="0" err="1"/>
-                  <a:t>ràng</a:t>
+                  <a:t>nhỏ</a:t>
+                </a:r>
+                <a:r>
+                  <a:rPr lang="en-US" dirty="0"/>
+                  <a:t> </a:t>
+                </a:r>
+                <a:r>
+                  <a:rPr lang="en-US" dirty="0" err="1"/>
+                  <a:t>nhất</a:t>
+                </a:r>
+                <a:r>
+                  <a:rPr lang="en-US" dirty="0"/>
+                  <a:t> </a:t>
+                </a:r>
+                <a:r>
+                  <a:rPr lang="en-US" dirty="0" err="1"/>
+                  <a:t>giữa</a:t>
+                </a:r>
+                <a:r>
+                  <a:rPr lang="en-US" dirty="0"/>
+                  <a:t> </a:t>
+                </a:r>
+                <a:r>
+                  <a:rPr lang="en-US" dirty="0" err="1"/>
+                  <a:t>hai</a:t>
+                </a:r>
+                <a:r>
+                  <a:rPr lang="en-US" dirty="0"/>
+                  <a:t> </a:t>
+                </a:r>
+                <a:r>
+                  <a:rPr lang="en-US" dirty="0" err="1"/>
+                  <a:t>khách</a:t>
                 </a:r>
                 <a:endParaRPr lang="en-US" dirty="0"/>
               </a:p>
@@ -16102,91 +16431,114 @@
                 </a:pPr>
                 <a:r>
                   <a:rPr lang="en-US" dirty="0" err="1"/>
-                  <a:t>buộc</a:t>
-                </a:r>
-                <a:r>
-                  <a:rPr lang="en-US" dirty="0"/>
-                  <a:t> </a:t>
-                </a:r>
-                <a:r>
-                  <a:rPr lang="en-US" dirty="0" err="1"/>
-                  <a:t>cửa</a:t>
-                </a:r>
-                <a:r>
-                  <a:rPr lang="en-US" dirty="0"/>
-                  <a:t> </a:t>
-                </a:r>
-                <a:r>
-                  <a:rPr lang="en-US" dirty="0" err="1"/>
-                  <a:t>sổ</a:t>
-                </a:r>
-                <a:endParaRPr lang="en-US" dirty="0"/>
+                  <a:t>bất</a:t>
+                </a:r>
+                <a:r>
+                  <a:rPr lang="en-US" dirty="0"/>
+                  <a:t> </a:t>
+                </a:r>
+                <a:r>
+                  <a:rPr lang="en-US" dirty="0" err="1"/>
+                  <a:t>kỳ</a:t>
+                </a:r>
+                <a:r>
+                  <a:rPr lang="en-US" dirty="0"/>
+                  <a:t> (</a:t>
+                </a:r>
+                <a:r>
+                  <a:rPr lang="en-US" dirty="0" err="1"/>
+                  <a:t>coi</a:t>
+                </a:r>
+                <a:r>
+                  <a:rPr lang="en-US" dirty="0"/>
+                  <a:t> </a:t>
+                </a:r>
+                <a:r>
+                  <a:rPr lang="en-US" dirty="0" err="1"/>
+                  <a:t>kho</a:t>
+                </a:r>
+                <a:r>
+                  <a:rPr lang="en-US" dirty="0"/>
+                  <a:t> </a:t>
+                </a:r>
+                <a:r>
+                  <a:rPr lang="en-US" dirty="0" err="1"/>
+                  <a:t>là</a:t>
+                </a:r>
+                <a:r>
+                  <a:rPr lang="en-US" dirty="0"/>
+                  <a:t> </a:t>
+                </a:r>
+                <a:r>
+                  <a:rPr lang="en-US" dirty="0" err="1"/>
+                  <a:t>khách</a:t>
+                </a:r>
+                <a:r>
+                  <a:rPr lang="en-US" dirty="0"/>
+                  <a:t> </a:t>
+                </a:r>
+                <a14:m>
+                  <m:oMath xmlns:m="http://schemas.openxmlformats.org/officeDocument/2006/math">
+                    <m:r>
+                      <a:rPr lang="en-US" b="0" i="1" smtClean="0">
+                        <a:latin typeface="Cambria Math" panose="02040503050406030204" pitchFamily="18" charset="0"/>
+                      </a:rPr>
+                      <m:t>0</m:t>
+                    </m:r>
+                  </m:oMath>
+                </a14:m>
+                <a:r>
+                  <a:rPr lang="en-US" dirty="0"/>
+                  <a:t>).</a:t>
+                </a:r>
+              </a:p>
+              <a:p>
+                <a:pPr algn="just"/>
+                <a:r>
+                  <a:rPr lang="en-US" dirty="0" err="1"/>
+                  <a:t>Độ</a:t>
+                </a:r>
+                <a:r>
+                  <a:rPr lang="en-US" dirty="0"/>
+                  <a:t> </a:t>
+                </a:r>
+                <a:r>
+                  <a:rPr lang="en-US" dirty="0" err="1"/>
+                  <a:t>phức</a:t>
+                </a:r>
+                <a:r>
+                  <a:rPr lang="en-US" dirty="0"/>
+                  <a:t> </a:t>
+                </a:r>
+                <a:r>
+                  <a:rPr lang="en-US" dirty="0" err="1"/>
+                  <a:t>tạp</a:t>
+                </a:r>
+                <a:r>
+                  <a:rPr lang="en-US" dirty="0"/>
+                  <a:t> </a:t>
+                </a:r>
+                <a:r>
+                  <a:rPr lang="en-US" dirty="0" err="1"/>
+                  <a:t>thời</a:t>
+                </a:r>
+                <a:r>
+                  <a:rPr lang="en-US" dirty="0"/>
+                  <a:t> </a:t>
+                </a:r>
+                <a:r>
+                  <a:rPr lang="en-US" dirty="0" err="1"/>
+                  <a:t>gian</a:t>
+                </a:r>
+                <a:r>
+                  <a:rPr lang="en-US" dirty="0"/>
+                  <a:t>:</a:t>
+                </a:r>
               </a:p>
               <a:p>
                 <a:pPr marL="0" indent="0" algn="just">
                   <a:buNone/>
                 </a:pPr>
-                <a:r>
-                  <a:rPr lang="en-US" dirty="0" err="1"/>
-                  <a:t>thời</a:t>
-                </a:r>
-                <a:r>
-                  <a:rPr lang="en-US" dirty="0"/>
-                  <a:t> </a:t>
-                </a:r>
-                <a:r>
-                  <a:rPr lang="en-US" dirty="0" err="1"/>
-                  <a:t>gian</a:t>
-                </a:r>
-                <a:r>
-                  <a:rPr lang="en-US" dirty="0"/>
-                  <a:t>.</a:t>
-                </a:r>
-              </a:p>
-              <a:p>
-                <a:pPr algn="just"/>
-                <a:r>
-                  <a:rPr lang="en-US" dirty="0" err="1"/>
-                  <a:t>Độ</a:t>
-                </a:r>
-                <a:r>
-                  <a:rPr lang="en-US" dirty="0"/>
-                  <a:t> </a:t>
-                </a:r>
-                <a:r>
-                  <a:rPr lang="en-US" dirty="0" err="1"/>
-                  <a:t>phức</a:t>
-                </a:r>
-                <a:r>
-                  <a:rPr lang="en-US" dirty="0"/>
-                  <a:t> </a:t>
-                </a:r>
-                <a:r>
-                  <a:rPr lang="en-US" dirty="0" err="1"/>
-                  <a:t>tạp</a:t>
-                </a:r>
-                <a:endParaRPr lang="en-US" dirty="0"/>
-              </a:p>
-              <a:p>
-                <a:pPr marL="0" indent="0" algn="just">
-                  <a:buNone/>
-                </a:pPr>
-                <a:r>
-                  <a:rPr lang="en-US" dirty="0" err="1"/>
-                  <a:t>thời</a:t>
-                </a:r>
-                <a:r>
-                  <a:rPr lang="en-US" dirty="0"/>
-                  <a:t> </a:t>
-                </a:r>
-                <a:r>
-                  <a:rPr lang="en-US" dirty="0" err="1"/>
-                  <a:t>gian</a:t>
-                </a:r>
-                <a:r>
-                  <a:rPr lang="en-US" dirty="0"/>
-                  <a:t>: </a:t>
-                </a:r>
                 <a14:m>
                   <m:oMath xmlns:m="http://schemas.openxmlformats.org/officeDocument/2006/math">
                     <m:r>
@@ -16231,7 +16583,7 @@
             </p:txBody>
           </p:sp>
         </mc:Choice>
-        <mc:Fallback xmlns="">
+        <mc:Fallback>
           <p:sp>
             <p:nvSpPr>
               <p:cNvPr id="4" name="Text Placeholder 3">
@@ -16287,14 +16639,15 @@
         </p:nvPicPr>
         <p:blipFill>
           <a:blip r:embed="rId3"/>
+          <a:srcRect l="1842" r="13003"/>
           <a:stretch>
             <a:fillRect/>
           </a:stretch>
         </p:blipFill>
         <p:spPr>
           <a:xfrm>
-            <a:off x="2845999" y="1735738"/>
-            <a:ext cx="6062924" cy="4052503"/>
+            <a:off x="4572000" y="1827495"/>
+            <a:ext cx="4336923" cy="3404178"/>
           </a:xfrm>
           <a:prstGeom prst="rect">
             <a:avLst/>
@@ -17132,8 +17485,8 @@
           </a:p>
         </p:txBody>
       </p:sp>
-      <mc:AlternateContent xmlns:mc="http://schemas.openxmlformats.org/markup-compatibility/2006" xmlns:a14="http://schemas.microsoft.com/office/drawing/2010/main">
-        <mc:Choice Requires="a14">
+      <mc:AlternateContent xmlns:mc="http://schemas.openxmlformats.org/markup-compatibility/2006">
+        <mc:Choice xmlns:a14="http://schemas.microsoft.com/office/drawing/2010/main" Requires="a14">
           <p:sp>
             <p:nvSpPr>
               <p:cNvPr id="4" name="Text Placeholder 3">
@@ -17256,6 +17609,14 @@
                 <a:r>
                   <a:rPr lang="en-US" dirty="0" err="1"/>
                   <a:t>tạo</a:t>
+                </a:r>
+                <a:r>
+                  <a:rPr lang="en-US" dirty="0"/>
+                  <a:t> </a:t>
+                </a:r>
+                <a:r>
+                  <a:rPr lang="en-US" dirty="0" err="1"/>
+                  <a:t>các</a:t>
                 </a:r>
                 <a:r>
                   <a:rPr lang="en-US" dirty="0"/>
@@ -17770,6 +18131,62 @@
                 <a:pPr marL="0" indent="0" algn="just">
                   <a:buNone/>
                 </a:pPr>
+                <a14:m>
+                  <m:oMathPara xmlns:m="http://schemas.openxmlformats.org/officeDocument/2006/math">
+                    <m:oMathParaPr>
+                      <m:jc m:val="centerGroup"/>
+                    </m:oMathParaPr>
+                    <m:oMath xmlns:m="http://schemas.openxmlformats.org/officeDocument/2006/math">
+                      <m:r>
+                        <a:rPr lang="en-US" i="1">
+                          <a:latin typeface="Cambria Math" panose="02040503050406030204" pitchFamily="18" charset="0"/>
+                        </a:rPr>
+                        <m:t>𝑓</m:t>
+                      </m:r>
+                      <m:d>
+                        <m:dPr>
+                          <m:ctrlPr>
+                            <a:rPr lang="en-US" i="1">
+                              <a:latin typeface="Cambria Math" panose="02040503050406030204" pitchFamily="18" charset="0"/>
+                            </a:rPr>
+                          </m:ctrlPr>
+                        </m:dPr>
+                        <m:e>
+                          <m:r>
+                            <a:rPr lang="en-US" i="1">
+                              <a:latin typeface="Cambria Math" panose="02040503050406030204" pitchFamily="18" charset="0"/>
+                            </a:rPr>
+                            <m:t>𝑆</m:t>
+                          </m:r>
+                          <m:r>
+                            <a:rPr lang="en-US" i="1">
+                              <a:latin typeface="Cambria Math" panose="02040503050406030204" pitchFamily="18" charset="0"/>
+                            </a:rPr>
+                            <m:t>, </m:t>
+                          </m:r>
+                          <m:r>
+                            <a:rPr lang="en-US" i="1">
+                              <a:latin typeface="Cambria Math" panose="02040503050406030204" pitchFamily="18" charset="0"/>
+                            </a:rPr>
+                            <m:t>𝑖</m:t>
+                          </m:r>
+                          <m:r>
+                            <a:rPr lang="en-US" i="1">
+                              <a:latin typeface="Cambria Math" panose="02040503050406030204" pitchFamily="18" charset="0"/>
+                            </a:rPr>
+                            <m:t>, </m:t>
+                          </m:r>
+                          <m:r>
+                            <a:rPr lang="en-US" i="1">
+                              <a:latin typeface="Cambria Math" panose="02040503050406030204" pitchFamily="18" charset="0"/>
+                            </a:rPr>
+                            <m:t>𝑥</m:t>
+                          </m:r>
+                        </m:e>
+                      </m:d>
+                    </m:oMath>
+                  </m:oMathPara>
+                </a14:m>
                 <a:endParaRPr lang="en-US" dirty="0"/>
               </a:p>
               <a:p>
@@ -17782,59 +18199,6 @@
                       <m:jc m:val="centerGroup"/>
                     </m:oMathParaPr>
                     <m:oMath xmlns:m="http://schemas.openxmlformats.org/officeDocument/2006/math">
-                      <m:r>
-                        <a:rPr lang="en-US" sz="2250" b="0" i="1" smtClean="0">
-                          <a:latin typeface="Cambria Math" panose="02040503050406030204" pitchFamily="18" charset="0"/>
-                        </a:rPr>
-                        <m:t>     </m:t>
-                      </m:r>
-                      <m:r>
-                        <a:rPr lang="en-US" sz="2250" i="1">
-                          <a:latin typeface="Cambria Math" panose="02040503050406030204" pitchFamily="18" charset="0"/>
-                        </a:rPr>
-                        <m:t>𝑓</m:t>
-                      </m:r>
-                      <m:d>
-                        <m:dPr>
-                          <m:ctrlPr>
-                            <a:rPr lang="en-US" sz="2250" i="1">
-                              <a:latin typeface="Cambria Math" panose="02040503050406030204" pitchFamily="18" charset="0"/>
-                            </a:rPr>
-                          </m:ctrlPr>
-                        </m:dPr>
-                        <m:e>
-                          <m:r>
-                            <a:rPr lang="en-US" sz="2250" i="1">
-                              <a:latin typeface="Cambria Math" panose="02040503050406030204" pitchFamily="18" charset="0"/>
-                            </a:rPr>
-                            <m:t>𝑆</m:t>
-                          </m:r>
-                          <m:r>
-                            <a:rPr lang="en-US" sz="2250" i="1">
-                              <a:latin typeface="Cambria Math" panose="02040503050406030204" pitchFamily="18" charset="0"/>
-                            </a:rPr>
-                            <m:t>, </m:t>
-                          </m:r>
-                          <m:r>
-                            <a:rPr lang="en-US" sz="2250" i="1">
-                              <a:latin typeface="Cambria Math" panose="02040503050406030204" pitchFamily="18" charset="0"/>
-                            </a:rPr>
-                            <m:t>𝑖</m:t>
-                          </m:r>
-                          <m:r>
-                            <a:rPr lang="en-US" sz="2250" i="1">
-                              <a:latin typeface="Cambria Math" panose="02040503050406030204" pitchFamily="18" charset="0"/>
-                            </a:rPr>
-                            <m:t>, </m:t>
-                          </m:r>
-                          <m:r>
-                            <a:rPr lang="en-US" sz="2250" i="1">
-                              <a:latin typeface="Cambria Math" panose="02040503050406030204" pitchFamily="18" charset="0"/>
-                            </a:rPr>
-                            <m:t>𝑥</m:t>
-                          </m:r>
-                        </m:e>
-                      </m:d>
                       <m:r>
                         <a:rPr lang="en-US" sz="2250" i="1">
                           <a:latin typeface="Cambria Math" panose="02040503050406030204" pitchFamily="18" charset="0"/>
@@ -18472,7 +18836,7 @@
             </p:txBody>
           </p:sp>
         </mc:Choice>
-        <mc:Fallback xmlns="">
+        <mc:Fallback>
           <p:sp>
             <p:nvSpPr>
               <p:cNvPr id="4" name="Text Placeholder 3">
@@ -18610,8 +18974,8 @@
           </a:p>
         </p:txBody>
       </p:sp>
-      <mc:AlternateContent xmlns:mc="http://schemas.openxmlformats.org/markup-compatibility/2006" xmlns:a14="http://schemas.microsoft.com/office/drawing/2010/main">
-        <mc:Choice Requires="a14">
+      <mc:AlternateContent xmlns:mc="http://schemas.openxmlformats.org/markup-compatibility/2006">
+        <mc:Choice xmlns:a14="http://schemas.microsoft.com/office/drawing/2010/main" Requires="a14">
           <p:sp>
             <p:nvSpPr>
               <p:cNvPr id="4" name="Text Placeholder 3">
@@ -18836,25 +19200,23 @@
                           </m:limLow>
                         </m:fName>
                         <m:e>
-                          <m:r>
-                            <a:rPr lang="en-US" i="1">
-                              <a:latin typeface="Cambria Math" panose="02040503050406030204" pitchFamily="18" charset="0"/>
-                            </a:rPr>
-                            <m:t>𝑓</m:t>
-                          </m:r>
                           <m:d>
                             <m:dPr>
                               <m:ctrlPr>
-                                <a:rPr lang="en-US" i="1">
+                                <a:rPr lang="en-US" b="0" i="1" smtClean="0">
                                   <a:latin typeface="Cambria Math" panose="02040503050406030204" pitchFamily="18" charset="0"/>
                                 </a:rPr>
                               </m:ctrlPr>
                             </m:dPr>
                             <m:e>
+                              <m:r>
+                                <a:rPr lang="en-US" i="1">
+                                  <a:latin typeface="Cambria Math" panose="02040503050406030204" pitchFamily="18" charset="0"/>
+                                </a:rPr>
+                                <m:t>𝑓</m:t>
+                              </m:r>
                               <m:d>
                                 <m:dPr>
-                                  <m:begChr m:val="{"/>
-                                  <m:endChr m:val="}"/>
                                   <m:ctrlPr>
                                     <a:rPr lang="en-US" i="1">
                                       <a:latin typeface="Cambria Math" panose="02040503050406030204" pitchFamily="18" charset="0"/>
@@ -18862,17 +19224,60 @@
                                   </m:ctrlPr>
                                 </m:dPr>
                                 <m:e>
+                                  <m:d>
+                                    <m:dPr>
+                                      <m:begChr m:val="{"/>
+                                      <m:endChr m:val="}"/>
+                                      <m:ctrlPr>
+                                        <a:rPr lang="en-US" i="1">
+                                          <a:latin typeface="Cambria Math" panose="02040503050406030204" pitchFamily="18" charset="0"/>
+                                        </a:rPr>
+                                      </m:ctrlPr>
+                                    </m:dPr>
+                                    <m:e>
+                                      <m:r>
+                                        <a:rPr lang="en-US" i="1">
+                                          <a:latin typeface="Cambria Math" panose="02040503050406030204" pitchFamily="18" charset="0"/>
+                                        </a:rPr>
+                                        <m:t>1, 2, …, </m:t>
+                                      </m:r>
+                                      <m:r>
+                                        <a:rPr lang="en-US" i="1">
+                                          <a:latin typeface="Cambria Math" panose="02040503050406030204" pitchFamily="18" charset="0"/>
+                                        </a:rPr>
+                                        <m:t>𝑛</m:t>
+                                      </m:r>
+                                    </m:e>
+                                  </m:d>
                                   <m:r>
                                     <a:rPr lang="en-US" i="1">
                                       <a:latin typeface="Cambria Math" panose="02040503050406030204" pitchFamily="18" charset="0"/>
                                     </a:rPr>
-                                    <m:t>1, 2, …, </m:t>
+                                    <m:t>, </m:t>
                                   </m:r>
                                   <m:r>
                                     <a:rPr lang="en-US" i="1">
                                       <a:latin typeface="Cambria Math" panose="02040503050406030204" pitchFamily="18" charset="0"/>
                                     </a:rPr>
-                                    <m:t>𝑛</m:t>
+                                    <m:t>𝑗</m:t>
+                                  </m:r>
+                                  <m:r>
+                                    <a:rPr lang="en-US" i="1">
+                                      <a:latin typeface="Cambria Math" panose="02040503050406030204" pitchFamily="18" charset="0"/>
+                                    </a:rPr>
+                                    <m:t>, </m:t>
+                                  </m:r>
+                                  <m:r>
+                                    <a:rPr lang="en-US" i="1">
+                                      <a:latin typeface="Cambria Math" panose="02040503050406030204" pitchFamily="18" charset="0"/>
+                                    </a:rPr>
+                                    <m:t>𝑥</m:t>
+                                  </m:r>
+                                  <m:r>
+                                    <a:rPr lang="en-US" i="1">
+                                      <a:latin typeface="Cambria Math" panose="02040503050406030204" pitchFamily="18" charset="0"/>
+                                    </a:rPr>
+                                    <m:t>′</m:t>
                                   </m:r>
                                 </m:e>
                               </m:d>
@@ -18880,73 +19285,43 @@
                                 <a:rPr lang="en-US" i="1">
                                   <a:latin typeface="Cambria Math" panose="02040503050406030204" pitchFamily="18" charset="0"/>
                                 </a:rPr>
-                                <m:t>, </m:t>
+                                <m:t>+</m:t>
                               </m:r>
-                              <m:r>
-                                <a:rPr lang="en-US" i="1">
-                                  <a:latin typeface="Cambria Math" panose="02040503050406030204" pitchFamily="18" charset="0"/>
-                                </a:rPr>
-                                <m:t>𝑗</m:t>
-                              </m:r>
-                              <m:r>
-                                <a:rPr lang="en-US" i="1">
-                                  <a:latin typeface="Cambria Math" panose="02040503050406030204" pitchFamily="18" charset="0"/>
-                                </a:rPr>
-                                <m:t>, </m:t>
-                              </m:r>
-                              <m:r>
-                                <a:rPr lang="en-US" i="1">
-                                  <a:latin typeface="Cambria Math" panose="02040503050406030204" pitchFamily="18" charset="0"/>
-                                </a:rPr>
-                                <m:t>𝑥</m:t>
-                              </m:r>
-                              <m:r>
-                                <a:rPr lang="en-US" i="1">
-                                  <a:latin typeface="Cambria Math" panose="02040503050406030204" pitchFamily="18" charset="0"/>
-                                </a:rPr>
-                                <m:t>′</m:t>
-                              </m:r>
+                              <m:sSub>
+                                <m:sSubPr>
+                                  <m:ctrlPr>
+                                    <a:rPr lang="en-US" i="1">
+                                      <a:latin typeface="Cambria Math" panose="02040503050406030204" pitchFamily="18" charset="0"/>
+                                    </a:rPr>
+                                  </m:ctrlPr>
+                                </m:sSubPr>
+                                <m:e>
+                                  <m:r>
+                                    <a:rPr lang="en-US" i="1">
+                                      <a:latin typeface="Cambria Math" panose="02040503050406030204" pitchFamily="18" charset="0"/>
+                                    </a:rPr>
+                                    <m:t>𝑡</m:t>
+                                  </m:r>
+                                </m:e>
+                                <m:sub>
+                                  <m:r>
+                                    <a:rPr lang="en-US" i="1">
+                                      <a:latin typeface="Cambria Math" panose="02040503050406030204" pitchFamily="18" charset="0"/>
+                                    </a:rPr>
+                                    <m:t>𝑗</m:t>
+                                  </m:r>
+                                  <m:r>
+                                    <a:rPr lang="en-US" i="1">
+                                      <a:latin typeface="Cambria Math" panose="02040503050406030204" pitchFamily="18" charset="0"/>
+                                    </a:rPr>
+                                    <m:t>, 0</m:t>
+                                  </m:r>
+                                </m:sub>
+                              </m:sSub>
                             </m:e>
                           </m:d>
                         </m:e>
                       </m:func>
-                      <m:r>
-                        <a:rPr lang="en-US" i="1">
-                          <a:latin typeface="Cambria Math" panose="02040503050406030204" pitchFamily="18" charset="0"/>
-                        </a:rPr>
-                        <m:t>+</m:t>
-                      </m:r>
-                      <m:sSub>
-                        <m:sSubPr>
-                          <m:ctrlPr>
-                            <a:rPr lang="en-US" i="1">
-                              <a:latin typeface="Cambria Math" panose="02040503050406030204" pitchFamily="18" charset="0"/>
-                            </a:rPr>
-                          </m:ctrlPr>
-                        </m:sSubPr>
-                        <m:e>
-                          <m:r>
-                            <a:rPr lang="en-US" i="1">
-                              <a:latin typeface="Cambria Math" panose="02040503050406030204" pitchFamily="18" charset="0"/>
-                            </a:rPr>
-                            <m:t>𝑡</m:t>
-                          </m:r>
-                        </m:e>
-                        <m:sub>
-                          <m:r>
-                            <a:rPr lang="en-US" i="1">
-                              <a:latin typeface="Cambria Math" panose="02040503050406030204" pitchFamily="18" charset="0"/>
-                            </a:rPr>
-                            <m:t>𝑗</m:t>
-                          </m:r>
-                          <m:r>
-                            <a:rPr lang="en-US" i="1">
-                              <a:latin typeface="Cambria Math" panose="02040503050406030204" pitchFamily="18" charset="0"/>
-                            </a:rPr>
-                            <m:t>, 0</m:t>
-                          </m:r>
-                        </m:sub>
-                      </m:sSub>
                       <m:r>
                         <a:rPr lang="en-US" b="0" i="1" smtClean="0">
                           <a:latin typeface="Cambria Math" panose="02040503050406030204" pitchFamily="18" charset="0"/>
@@ -19132,22 +19507,6 @@
                 </a:r>
                 <a:r>
                   <a:rPr lang="en-US" dirty="0"/>
-                  <a:t> </a:t>
-                </a:r>
-                <a:r>
-                  <a:rPr lang="en-US" dirty="0" err="1"/>
-                  <a:t>thuật</a:t>
-                </a:r>
-                <a:r>
-                  <a:rPr lang="en-US" dirty="0"/>
-                  <a:t> </a:t>
-                </a:r>
-                <a:r>
-                  <a:rPr lang="en-US" dirty="0" err="1"/>
-                  <a:t>toán</a:t>
-                </a:r>
-                <a:r>
-                  <a:rPr lang="en-US" dirty="0"/>
                   <a:t> quay </a:t>
                 </a:r>
                 <a:r>
@@ -19308,7 +19667,7 @@
             </p:txBody>
           </p:sp>
         </mc:Choice>
-        <mc:Fallback xmlns="">
+        <mc:Fallback>
           <p:sp>
             <p:nvSpPr>
               <p:cNvPr id="4" name="Text Placeholder 3">

</xml_diff>